<commit_message>
Update BasedMarketLab presentation for Base mainnet.
Refresh how-it-works PDF/PPTX for $0.10 USDC on Base mainnet, one chart, no testnet free unlock. Keep site presentations-only; product remains closed source.
</commit_message>
<xml_diff>
--- a/presentations/BasedMarketLab-How-It-Works.pptx
+++ b/presentations/BasedMarketLab-How-It-Works.pptx
@@ -2037,7 +2037,7 @@
                 <a:ea typeface="Arial" pitchFamily="34" charset="-122"/>
                 <a:cs typeface="Arial" pitchFamily="34" charset="-120"/>
               </a:rPr>
-              <a:t>Product walkthrough for demos, partners &amp; Base ecosystem</a:t>
+              <a:t>Product walkthrough · closed product · payments on Base mainnet</a:t>
             </a:r>
             <a:endParaRPr lang="en-US" sz="1200" dirty="0"/>
           </a:p>
@@ -2971,7 +2971,7 @@
                 <a:ea typeface="Arial" pitchFamily="34" charset="-122"/>
                 <a:cs typeface="Arial" pitchFamily="34" charset="-120"/>
               </a:rPr>
-              <a:t>Mainnet or Sepolia demo</a:t>
+              <a:t>Base mainnet only</a:t>
             </a:r>
             <a:endParaRPr lang="en-US" sz="1200" dirty="0"/>
           </a:p>
@@ -3071,7 +3071,7 @@
                 <a:ea typeface="Arial" pitchFamily="34" charset="-122"/>
                 <a:cs typeface="Arial" pitchFamily="34" charset="-120"/>
               </a:rPr>
-              <a:t>AI keys never leave the user’s browser · Research prompts stay on the server · Payment is verified on-chain before generate unlock · Desktop app is for you; public host is for customers later.</a:t>
+              <a:t>AI keys stay with the user · Research prompts stay on the server · $0.10 USDC verified on Base mainnet before unlock · Product source stays private (closed) · GitHub site is presentations only.</a:t>
             </a:r>
             <a:endParaRPr lang="en-US" sz="1200" dirty="0"/>
           </a:p>
@@ -3331,7 +3331,7 @@
                 <a:ea typeface="Arial" pitchFamily="34" charset="-122"/>
                 <a:cs typeface="Arial" pitchFamily="34" charset="-120"/>
               </a:rPr>
-              <a:t>Demo path: free example → COIN generate → confirm → pay/unlock → Company / Full / Chart tabs.</a:t>
+              <a:t>Path: ticker → research → confirm → pay $0.10 USDC on Base → Company / Full / Chart tabs.</a:t>
             </a:r>
             <a:endParaRPr lang="en-US" sz="1400" dirty="0"/>
           </a:p>
@@ -3370,7 +3370,7 @@
                 <a:ea typeface="Arial" pitchFamily="34" charset="-122"/>
                 <a:cs typeface="Arial" pitchFamily="34" charset="-120"/>
               </a:rPr>
-              <a:t>Built on Base  ·  Local app today  ·  Hosted product next</a:t>
+              <a:t>Built on Base  ·  Closed product  ·  Public presentations only</a:t>
             </a:r>
             <a:endParaRPr lang="en-US" sz="1300" dirty="0"/>
           </a:p>
@@ -3518,7 +3518,7 @@
                 <a:ea typeface="Arial" pitchFamily="34" charset="-122"/>
                 <a:cs typeface="Arial" pitchFamily="34" charset="-120"/>
               </a:rPr>
-              <a:t>BasedMarketLab turns a stock ticker into a clear company research report — what the business does, strengths, risks, and longer-term story — then unlocks the full package for $0.50 USDC on Base.</a:t>
+              <a:t>BasedMarketLab turns a stock ticker into a clear company research report — what the business does, strengths, risks, and longer-term story — then unlocks the full package for $0.10 USDC on Base.</a:t>
             </a:r>
             <a:endParaRPr lang="en-US" sz="1500" dirty="0"/>
           </a:p>
@@ -3899,7 +3899,7 @@
                 <a:ea typeface="Arial" pitchFamily="34" charset="-122"/>
                 <a:cs typeface="Arial" pitchFamily="34" charset="-120"/>
               </a:rPr>
-              <a:t>Pay with USDC on Base (or Base Sepolia for demos). Wallet connect included.</a:t>
+              <a:t>Pay $0.10 USDC on Base mainnet. Wallet connect · real on-chain unlock.</a:t>
             </a:r>
             <a:endParaRPr lang="en-US" sz="1300" dirty="0"/>
           </a:p>
@@ -4714,7 +4714,7 @@
                 <a:ea typeface="Arial" pitchFamily="34" charset="-122"/>
                 <a:cs typeface="Arial" pitchFamily="34" charset="-120"/>
               </a:rPr>
-              <a:t>$0.50 USDC on Base (or testnet for demos).</a:t>
+              <a:t>$0.10 USDC on Base mainnet (real USDC only).</a:t>
             </a:r>
             <a:endParaRPr lang="en-US" sz="1400" dirty="0"/>
           </a:p>
@@ -4851,7 +4851,7 @@
                 <a:ea typeface="Arial" pitchFamily="34" charset="-122"/>
                 <a:cs typeface="Arial" pitchFamily="34" charset="-120"/>
               </a:rPr>
-              <a:t>Company · Full · Chart · Predictions · PDF / library.</a:t>
+              <a:t>Company · Full · one Price chart · Predictions · PDF / library.</a:t>
             </a:r>
             <a:endParaRPr lang="en-US" sz="1400" dirty="0"/>
           </a:p>
@@ -5184,7 +5184,7 @@
                 <a:ea typeface="Arial" pitchFamily="34" charset="-122"/>
                 <a:cs typeface="Arial" pitchFamily="34" charset="-120"/>
               </a:rPr>
-              <a:t>•  Yahoo / market feeds + company blurbs</a:t>
+              <a:t>•  Public market feeds + company context</a:t>
             </a:r>
             <a:endParaRPr lang="en-US" sz="1300" dirty="0"/>
           </a:p>
@@ -5223,7 +5223,7 @@
                 <a:ea typeface="Arial" pitchFamily="34" charset="-122"/>
                 <a:cs typeface="Arial" pitchFamily="34" charset="-120"/>
               </a:rPr>
-              <a:t>•  Charts &amp; structure still build</a:t>
+              <a:t>•  One full-history chart still builds</a:t>
             </a:r>
             <a:endParaRPr lang="en-US" sz="1300" dirty="0"/>
           </a:p>
@@ -5340,7 +5340,7 @@
                 <a:ea typeface="Arial" pitchFamily="34" charset="-122"/>
                 <a:cs typeface="Arial" pitchFamily="34" charset="-120"/>
               </a:rPr>
-              <a:t>•  Works offline from free APIs</a:t>
+              <a:t>•  No AI key required for this path</a:t>
             </a:r>
             <a:endParaRPr lang="en-US" sz="1300" dirty="0"/>
           </a:p>
@@ -5861,7 +5861,7 @@
                 <a:ea typeface="Arial" pitchFamily="34" charset="-122"/>
                 <a:cs typeface="Arial" pitchFamily="34" charset="-120"/>
               </a:rPr>
-              <a:t>Ticker · optional AI key · Generate · $0.50 USDC</a:t>
+              <a:t>Ticker · optional AI key · Generate · $0.10 USDC</a:t>
             </a:r>
             <a:endParaRPr lang="en-US" sz="1100" dirty="0"/>
           </a:p>
@@ -6285,7 +6285,7 @@
                 <a:ea typeface="Arial" pitchFamily="34" charset="-122"/>
                 <a:cs typeface="Arial" pitchFamily="34" charset="-120"/>
               </a:rPr>
-              <a:t>MetaMask / Coinbase Wallet on Base (or Base Sepolia for demos).</a:t>
+              <a:t>MetaMask / Coinbase Wallet on Base mainnet (chain 8453).</a:t>
             </a:r>
             <a:endParaRPr lang="en-US" sz="1300" dirty="0"/>
           </a:p>
@@ -6353,7 +6353,7 @@
                 <a:ea typeface="Arial" pitchFamily="34" charset="-122"/>
                 <a:cs typeface="Arial" pitchFamily="34" charset="-120"/>
               </a:rPr>
-              <a:t>Pay $0.50 USDC</a:t>
+              <a:t>Pay $0.10 USDC</a:t>
             </a:r>
             <a:endParaRPr lang="en-US" sz="1500" dirty="0"/>
           </a:p>
@@ -6392,7 +6392,7 @@
                 <a:ea typeface="Arial" pitchFamily="34" charset="-122"/>
                 <a:cs typeface="Arial" pitchFamily="34" charset="-120"/>
               </a:rPr>
-              <a:t>On-chain transfer to your shop address. App verifies the tx, then unlocks.</a:t>
+              <a:t>Real USDC transfer to your shop address. App verifies the tx on Base, then unlocks.</a:t>
             </a:r>
             <a:endParaRPr lang="en-US" sz="1300" dirty="0"/>
           </a:p>
@@ -6460,7 +6460,7 @@
                 <a:ea typeface="Arial" pitchFamily="34" charset="-122"/>
                 <a:cs typeface="Arial" pitchFamily="34" charset="-120"/>
               </a:rPr>
-              <a:t>Demo modes</a:t>
+              <a:t>No free skip</a:t>
             </a:r>
             <a:endParaRPr lang="en-US" sz="1500" dirty="0"/>
           </a:p>
@@ -6499,7 +6499,7 @@
                 <a:ea typeface="Arial" pitchFamily="34" charset="-122"/>
                 <a:cs typeface="Arial" pitchFamily="34" charset="-120"/>
               </a:rPr>
-              <a:t>Testnet + free unlock available for presentations without real money.</a:t>
+              <a:t>Testnet and free unlock are off — production path is mainnet USDC only.</a:t>
             </a:r>
             <a:endParaRPr lang="en-US" sz="1300" dirty="0"/>
           </a:p>
@@ -6725,7 +6725,7 @@
                 <a:ea typeface="Arial" pitchFamily="34" charset="-122"/>
                 <a:cs typeface="Arial" pitchFamily="34" charset="-120"/>
               </a:rPr>
-              <a:t>Confirm company → connect MetaMask / Coinbase Wallet → pay $0.50 USDC on Base</a:t>
+              <a:t>Confirm company → connect MetaMask / Coinbase Wallet → pay $0.10 USDC on Base</a:t>
             </a:r>
             <a:endParaRPr lang="en-US" sz="1200" dirty="0"/>
           </a:p>
@@ -7235,7 +7235,7 @@
                 <a:ea typeface="Arial" pitchFamily="34" charset="-122"/>
                 <a:cs typeface="Arial" pitchFamily="34" charset="-120"/>
               </a:rPr>
-              <a:t>Tape, grades, zones — explicit secondary context, not the main product.</a:t>
+              <a:t>One full-history chart with buy/sell marks — secondary context, not the main product.</a:t>
             </a:r>
             <a:endParaRPr lang="en-US" sz="1300" dirty="0"/>
           </a:p>

</xml_diff>